<commit_message>
docs: fill in training report, deck and viva sheet in MUJ report format
- Report front pages follow the MUJ template: title page with logo,
  certificate for AIM 4170 signed by the faculty supervisor and HoD,
  Niva Bupa completion letter, acknowledgments, list of figures and tables.
- Real internship details (Niva Bupa Health Insurance, IT Applications,
  20 May - 20 Jul 2026) in the report, deck title slide and viva answers.

Co-Authored-By: Claude Opus 5.5 <noreply@anthropic.com>
</commit_message>
<xml_diff>
--- a/deliverables/Presentation.pptx
+++ b/deliverables/Presentation.pptx
@@ -124,7 +124,7 @@
   <p:extLst>
     <p:ext uri="{521415D9-36F7-43E2-AB2F-B90AF26B5E84}">
       <p14:sectionLst xmlns:p14="http://schemas.microsoft.com/office/powerpoint/2010/main">
-        <p14:section name="Introduction" id="{21e24e31-85e4-a3ed-c2de-7de98c461f0b}">
+        <p14:section name="Introduction" id="{a3415ed7-e4b0-d594-4bdf-b190ab8a1345}">
           <p14:sldIdLst>
             <p14:sldId id="256"/>
             <p14:sldId id="257"/>
@@ -132,14 +132,14 @@
             <p14:sldId id="259"/>
           </p14:sldIdLst>
         </p14:section>
-        <p14:section name="Methodology" id="{202e401b-5a12-1ebb-e069-95c025abed2b}">
+        <p14:section name="Methodology" id="{2b380a38-c374-cea9-6df9-6474985c0ae7}">
           <p14:sldIdLst>
             <p14:sldId id="260"/>
             <p14:sldId id="261"/>
             <p14:sldId id="262"/>
           </p14:sldIdLst>
         </p14:section>
-        <p14:section name="Design" id="{c5ce1ac7-cac1-2123-dc9b-cc753badb649}">
+        <p14:section name="Design" id="{df453058-ec7d-ed10-bb29-0c5a9930d71b}">
           <p14:sldIdLst>
             <p14:sldId id="263"/>
             <p14:sldId id="264"/>
@@ -148,14 +148,14 @@
             <p14:sldId id="267"/>
           </p14:sldIdLst>
         </p14:section>
-        <p14:section name="Results" id="{d4ff2d2a-8374-5743-87fb-475b2747bc35}">
+        <p14:section name="Results" id="{a16a976f-1a3b-4788-454e-956f1133c31a}">
           <p14:sldIdLst>
             <p14:sldId id="268"/>
             <p14:sldId id="269"/>
             <p14:sldId id="270"/>
           </p14:sldIdLst>
         </p14:section>
-        <p14:section name="Close" id="{6cc09123-2230-db42-f562-a665c3add32e}">
+        <p14:section name="Close" id="{4dec0058-3d82-addc-6a09-22c0dfc12e7c}">
           <p14:sldIdLst>
             <p14:sldId id="271"/>
             <p14:sldId id="272"/>
@@ -2903,7 +2903,7 @@
         <p:spPr>
           <a:xfrm>
             <a:off x="548640" y="5120640"/>
-            <a:ext cx="9144000" cy="1005840"/>
+            <a:ext cx="10515600" cy="1005840"/>
           </a:xfrm>
           <a:prstGeom prst="rect">
             <a:avLst/>
@@ -2927,7 +2927,7 @@
                 <a:ea typeface="Calibri" pitchFamily="34" charset="-122"/>
                 <a:cs typeface="Calibri" pitchFamily="34" charset="-120"/>
               </a:rPr>
-              <a:t>[YOUR NAME]  ·  [ROLL NUMBER]</a:t>
+              <a:t>Manvik Talwar  ·  23FE10CAI00130  ·  B.Tech CSE (AIML), 7th semester</a:t>
             </a:r>
             <a:endParaRPr lang="en-US" sz="1400" dirty="0"/>
           </a:p>
@@ -2944,7 +2944,7 @@
                 <a:ea typeface="Calibri" pitchFamily="34" charset="-122"/>
                 <a:cs typeface="Calibri" pitchFamily="34" charset="-120"/>
               </a:rPr>
-              <a:t>Industrial training at [ORGANISATION NAME]  ·  [INTERNSHIP DATES]</a:t>
+              <a:t>Industrial Training/Internship (AIM 4170)  ·  Niva Bupa Health Insurance, IT Applications  ·  20 May – 20 Jul 2026</a:t>
             </a:r>
             <a:endParaRPr lang="en-US" sz="1400" dirty="0"/>
           </a:p>
@@ -2961,7 +2961,7 @@
                 <a:ea typeface="Calibri" pitchFamily="34" charset="-122"/>
                 <a:cs typeface="Calibri" pitchFamily="34" charset="-120"/>
               </a:rPr>
-              <a:t>Mentor: [INDUSTRY MENTOR NAME]  ·  Guide: [FACULTY GUIDE NAME]</a:t>
+              <a:t>Reporting managers: Sudhanshu Jain, Rajat Gupta  ·  Faculty supervisor: Dr. Noopur Tyagi</a:t>
             </a:r>
             <a:endParaRPr lang="en-US" sz="1400" dirty="0"/>
           </a:p>
@@ -2969,7 +2969,58 @@
       </p:sp>
       <p:sp>
         <p:nvSpPr>
-          <p:cNvPr id="5" name="dot-2"/>
+          <p:cNvPr id="5" name="logo-card-2"/>
+          <p:cNvSpPr/>
+          <p:nvPr/>
+        </p:nvSpPr>
+        <p:spPr>
+          <a:xfrm>
+            <a:off x="548640" y="457200"/>
+            <a:ext cx="3383280" cy="868680"/>
+          </a:xfrm>
+          <a:prstGeom prst="roundRect">
+            <a:avLst>
+              <a:gd name="adj" fmla="val 10526"/>
+            </a:avLst>
+          </a:prstGeom>
+          <a:solidFill>
+            <a:schemeClr val="bg1"/>
+          </a:solidFill>
+          <a:ln w="12700">
+            <a:solidFill>
+              <a:schemeClr val="bg1"/>
+            </a:solidFill>
+            <a:prstDash val="solid"/>
+          </a:ln>
+        </p:spPr>
+      </p:sp>
+      <p:pic>
+        <p:nvPicPr>
+          <p:cNvPr id="6" name="logo-3" descr="Manipal University Jaipur logo">    </p:cNvPr>
+          <p:cNvPicPr>
+            <a:picLocks noChangeAspect="1"/>
+          </p:cNvPicPr>
+          <p:nvPr/>
+        </p:nvPicPr>
+        <p:blipFill>
+          <a:blip r:embed="rId1"/>
+          <a:stretch>
+            <a:fillRect/>
+          </a:stretch>
+        </p:blipFill>
+        <p:spPr>
+          <a:xfrm>
+            <a:off x="731520" y="566928"/>
+            <a:ext cx="3017520" cy="603504"/>
+          </a:xfrm>
+          <a:prstGeom prst="rect">
+            <a:avLst/>
+          </a:prstGeom>
+        </p:spPr>
+      </p:pic>
+      <p:sp>
+        <p:nvSpPr>
+          <p:cNvPr id="7" name="dot-4"/>
           <p:cNvSpPr/>
           <p:nvPr/>
         </p:nvSpPr>
@@ -2994,7 +3045,7 @@
       </p:sp>
       <p:sp>
         <p:nvSpPr>
-          <p:cNvPr id="6" name="txt-3"/>
+          <p:cNvPr id="8" name="txt-5"/>
           <p:cNvSpPr txBox="1"/>
           <p:nvPr/>
         </p:nvSpPr>
@@ -3033,7 +3084,7 @@
       </p:sp>
       <p:sp>
         <p:nvSpPr>
-          <p:cNvPr id="7" name="txt-4"/>
+          <p:cNvPr id="9" name="txt-6"/>
           <p:cNvSpPr txBox="1"/>
           <p:nvPr/>
         </p:nvSpPr>
@@ -3135,7 +3186,7 @@
       </p:sp>
       <p:pic>
         <p:nvPicPr>
-          <p:cNvPr id="3" name="img-161" descr="Seven gates from policy validation to state update with early-exit rules">    </p:cNvPr>
+          <p:cNvPr id="3" name="img-163" descr="Seven gates from policy validation to state update with early-exit rules">    </p:cNvPr>
           <p:cNvPicPr>
             <a:picLocks noChangeAspect="1"/>
           </p:cNvPicPr>
@@ -3267,7 +3318,7 @@
       </p:sp>
       <p:sp>
         <p:nvSpPr>
-          <p:cNvPr id="3" name="dot-162"/>
+          <p:cNvPr id="3" name="dot-164"/>
           <p:cNvSpPr/>
           <p:nvPr/>
         </p:nvSpPr>
@@ -3292,7 +3343,7 @@
       </p:sp>
       <p:sp>
         <p:nvSpPr>
-          <p:cNvPr id="4" name="txt-163"/>
+          <p:cNvPr id="4" name="txt-165"/>
           <p:cNvSpPr txBox="1"/>
           <p:nvPr/>
         </p:nvSpPr>
@@ -3331,7 +3382,7 @@
       </p:sp>
       <p:sp>
         <p:nvSpPr>
-          <p:cNvPr id="5" name="txt-164"/>
+          <p:cNvPr id="5" name="txt-166"/>
           <p:cNvSpPr txBox="1"/>
           <p:nvPr/>
         </p:nvSpPr>
@@ -3370,7 +3421,7 @@
       </p:sp>
       <p:sp>
         <p:nvSpPr>
-          <p:cNvPr id="6" name="txt-165"/>
+          <p:cNvPr id="6" name="txt-167"/>
           <p:cNvSpPr txBox="1"/>
           <p:nvPr/>
         </p:nvSpPr>
@@ -3409,7 +3460,7 @@
       </p:sp>
       <p:sp>
         <p:nvSpPr>
-          <p:cNvPr id="7" name="dot-166"/>
+          <p:cNvPr id="7" name="dot-168"/>
           <p:cNvSpPr/>
           <p:nvPr/>
         </p:nvSpPr>
@@ -3434,7 +3485,7 @@
       </p:sp>
       <p:sp>
         <p:nvSpPr>
-          <p:cNvPr id="8" name="txt-167"/>
+          <p:cNvPr id="8" name="txt-169"/>
           <p:cNvSpPr txBox="1"/>
           <p:nvPr/>
         </p:nvSpPr>
@@ -3473,7 +3524,7 @@
       </p:sp>
       <p:sp>
         <p:nvSpPr>
-          <p:cNvPr id="9" name="txt-168"/>
+          <p:cNvPr id="9" name="txt-170"/>
           <p:cNvSpPr txBox="1"/>
           <p:nvPr/>
         </p:nvSpPr>
@@ -3512,7 +3563,7 @@
       </p:sp>
       <p:sp>
         <p:nvSpPr>
-          <p:cNvPr id="10" name="txt-169"/>
+          <p:cNvPr id="10" name="txt-171"/>
           <p:cNvSpPr txBox="1"/>
           <p:nvPr/>
         </p:nvSpPr>
@@ -3551,7 +3602,7 @@
       </p:sp>
       <p:sp>
         <p:nvSpPr>
-          <p:cNvPr id="11" name="dot-170"/>
+          <p:cNvPr id="11" name="dot-172"/>
           <p:cNvSpPr/>
           <p:nvPr/>
         </p:nvSpPr>
@@ -3576,7 +3627,7 @@
       </p:sp>
       <p:sp>
         <p:nvSpPr>
-          <p:cNvPr id="12" name="txt-171"/>
+          <p:cNvPr id="12" name="txt-173"/>
           <p:cNvSpPr txBox="1"/>
           <p:nvPr/>
         </p:nvSpPr>
@@ -3615,7 +3666,7 @@
       </p:sp>
       <p:sp>
         <p:nvSpPr>
-          <p:cNvPr id="13" name="txt-172"/>
+          <p:cNvPr id="13" name="txt-174"/>
           <p:cNvSpPr txBox="1"/>
           <p:nvPr/>
         </p:nvSpPr>
@@ -3654,7 +3705,7 @@
       </p:sp>
       <p:sp>
         <p:nvSpPr>
-          <p:cNvPr id="14" name="txt-173"/>
+          <p:cNvPr id="14" name="txt-175"/>
           <p:cNvSpPr txBox="1"/>
           <p:nvPr/>
         </p:nvSpPr>
@@ -3693,7 +3744,7 @@
       </p:sp>
       <p:sp>
         <p:nvSpPr>
-          <p:cNvPr id="15" name="dot-174"/>
+          <p:cNvPr id="15" name="dot-176"/>
           <p:cNvSpPr/>
           <p:nvPr/>
         </p:nvSpPr>
@@ -3718,7 +3769,7 @@
       </p:sp>
       <p:sp>
         <p:nvSpPr>
-          <p:cNvPr id="16" name="txt-175"/>
+          <p:cNvPr id="16" name="txt-177"/>
           <p:cNvSpPr txBox="1"/>
           <p:nvPr/>
         </p:nvSpPr>
@@ -3757,7 +3808,7 @@
       </p:sp>
       <p:sp>
         <p:nvSpPr>
-          <p:cNvPr id="17" name="txt-176"/>
+          <p:cNvPr id="17" name="txt-178"/>
           <p:cNvSpPr txBox="1"/>
           <p:nvPr/>
         </p:nvSpPr>
@@ -3796,7 +3847,7 @@
       </p:sp>
       <p:sp>
         <p:nvSpPr>
-          <p:cNvPr id="18" name="txt-177"/>
+          <p:cNvPr id="18" name="txt-179"/>
           <p:cNvSpPr txBox="1"/>
           <p:nvPr/>
         </p:nvSpPr>
@@ -3835,7 +3886,7 @@
       </p:sp>
       <p:sp>
         <p:nvSpPr>
-          <p:cNvPr id="19" name="card-178"/>
+          <p:cNvPr id="19" name="card-180"/>
           <p:cNvSpPr/>
           <p:nvPr/>
         </p:nvSpPr>
@@ -3862,7 +3913,7 @@
       </p:sp>
       <p:sp>
         <p:nvSpPr>
-          <p:cNvPr id="20" name="txt-179"/>
+          <p:cNvPr id="20" name="txt-181"/>
           <p:cNvSpPr txBox="1"/>
           <p:nvPr/>
         </p:nvSpPr>
@@ -3901,7 +3952,7 @@
       </p:sp>
       <p:sp>
         <p:nvSpPr>
-          <p:cNvPr id="21" name="txt-180"/>
+          <p:cNvPr id="21" name="txt-182"/>
           <p:cNvSpPr txBox="1"/>
           <p:nvPr/>
         </p:nvSpPr>
@@ -3968,7 +4019,7 @@
       </p:sp>
       <p:sp>
         <p:nvSpPr>
-          <p:cNvPr id="22" name="txt-181"/>
+          <p:cNvPr id="22" name="txt-183"/>
           <p:cNvSpPr txBox="1"/>
           <p:nvPr/>
         </p:nvSpPr>
@@ -4115,7 +4166,7 @@
       </p:sp>
       <p:pic>
         <p:nvPicPr>
-          <p:cNvPr id="3" name="img-182" descr="Four confidence tiers: auto above 0.90, assisted review 0.70 to 0.90, medical review 0.50 to 0.70, pending review below 0.50">    </p:cNvPr>
+          <p:cNvPr id="3" name="img-184" descr="Four confidence tiers: auto above 0.90, assisted review 0.70 to 0.90, medical review 0.50 to 0.70, pending review below 0.50">    </p:cNvPr>
           <p:cNvPicPr>
             <a:picLocks noChangeAspect="1"/>
           </p:cNvPicPr>
@@ -4139,7 +4190,7 @@
       </p:pic>
       <p:sp>
         <p:nvSpPr>
-          <p:cNvPr id="4" name="txt-183"/>
+          <p:cNvPr id="4" name="txt-185"/>
           <p:cNvSpPr txBox="1"/>
           <p:nvPr/>
         </p:nvSpPr>
@@ -4286,7 +4337,7 @@
       </p:sp>
       <p:pic>
         <p:nvPicPr>
-          <p:cNvPr id="3" name="img-184" descr="Console showing partial approval, financial waterfall and AI explanation for scenario 1">    </p:cNvPr>
+          <p:cNvPr id="3" name="img-186" descr="Console showing partial approval, financial waterfall and AI explanation for scenario 1">    </p:cNvPr>
           <p:cNvPicPr>
             <a:picLocks noChangeAspect="1"/>
           </p:cNvPicPr>
@@ -4317,7 +4368,7 @@
       </p:pic>
       <p:sp>
         <p:nvSpPr>
-          <p:cNvPr id="4" name="card-185"/>
+          <p:cNvPr id="4" name="card-187"/>
           <p:cNvSpPr/>
           <p:nvPr/>
         </p:nvSpPr>
@@ -4344,7 +4395,7 @@
       </p:sp>
       <p:sp>
         <p:nvSpPr>
-          <p:cNvPr id="5" name="txt-186"/>
+          <p:cNvPr id="5" name="txt-188"/>
           <p:cNvSpPr txBox="1"/>
           <p:nvPr/>
         </p:nvSpPr>
@@ -4578,7 +4629,7 @@
       </p:sp>
       <p:graphicFrame>
         <p:nvGraphicFramePr>
-          <p:cNvPr id="15" name="tbl-187"/>
+          <p:cNvPr id="15" name="tbl-189"/>
           <p:cNvGraphicFramePr>
             <a:graphicFrameLocks noGrp="1"/>
           </p:cNvGraphicFramePr>
@@ -7196,7 +7247,7 @@
       </p:graphicFrame>
       <p:sp>
         <p:nvSpPr>
-          <p:cNvPr id="4" name="txt-188"/>
+          <p:cNvPr id="4" name="txt-190"/>
           <p:cNvSpPr txBox="1"/>
           <p:nvPr/>
         </p:nvSpPr>
@@ -7235,7 +7286,7 @@
       </p:sp>
       <p:sp>
         <p:nvSpPr>
-          <p:cNvPr id="5" name="txt-189"/>
+          <p:cNvPr id="5" name="txt-191"/>
           <p:cNvSpPr txBox="1"/>
           <p:nvPr/>
         </p:nvSpPr>
@@ -7274,7 +7325,7 @@
       </p:sp>
       <p:sp>
         <p:nvSpPr>
-          <p:cNvPr id="6" name="txt-190"/>
+          <p:cNvPr id="6" name="txt-192"/>
           <p:cNvSpPr txBox="1"/>
           <p:nvPr/>
         </p:nvSpPr>
@@ -7313,7 +7364,7 @@
       </p:sp>
       <p:sp>
         <p:nvSpPr>
-          <p:cNvPr id="7" name="txt-191"/>
+          <p:cNvPr id="7" name="txt-193"/>
           <p:cNvSpPr txBox="1"/>
           <p:nvPr/>
         </p:nvSpPr>
@@ -7352,7 +7403,7 @@
       </p:sp>
       <p:sp>
         <p:nvSpPr>
-          <p:cNvPr id="8" name="txt-192"/>
+          <p:cNvPr id="8" name="txt-194"/>
           <p:cNvSpPr txBox="1"/>
           <p:nvPr/>
         </p:nvSpPr>
@@ -7391,7 +7442,7 @@
       </p:sp>
       <p:sp>
         <p:nvSpPr>
-          <p:cNvPr id="9" name="txt-193"/>
+          <p:cNvPr id="9" name="txt-195"/>
           <p:cNvSpPr txBox="1"/>
           <p:nvPr/>
         </p:nvSpPr>
@@ -7538,7 +7589,7 @@
       </p:sp>
       <p:sp>
         <p:nvSpPr>
-          <p:cNvPr id="3" name="card-194"/>
+          <p:cNvPr id="3" name="card-196"/>
           <p:cNvSpPr/>
           <p:nvPr/>
         </p:nvSpPr>
@@ -7565,7 +7616,7 @@
       </p:sp>
       <p:sp>
         <p:nvSpPr>
-          <p:cNvPr id="4" name="txt-195"/>
+          <p:cNvPr id="4" name="txt-197"/>
           <p:cNvSpPr txBox="1"/>
           <p:nvPr/>
         </p:nvSpPr>
@@ -7604,7 +7655,7 @@
       </p:sp>
       <p:sp>
         <p:nvSpPr>
-          <p:cNvPr id="5" name="txt-196"/>
+          <p:cNvPr id="5" name="txt-198"/>
           <p:cNvSpPr txBox="1"/>
           <p:nvPr/>
         </p:nvSpPr>
@@ -7643,7 +7694,7 @@
       </p:sp>
       <p:sp>
         <p:nvSpPr>
-          <p:cNvPr id="6" name="card-197"/>
+          <p:cNvPr id="6" name="card-199"/>
           <p:cNvSpPr/>
           <p:nvPr/>
         </p:nvSpPr>
@@ -7670,7 +7721,7 @@
       </p:sp>
       <p:sp>
         <p:nvSpPr>
-          <p:cNvPr id="7" name="txt-198"/>
+          <p:cNvPr id="7" name="txt-200"/>
           <p:cNvSpPr txBox="1"/>
           <p:nvPr/>
         </p:nvSpPr>
@@ -7709,7 +7760,7 @@
       </p:sp>
       <p:sp>
         <p:nvSpPr>
-          <p:cNvPr id="8" name="txt-199"/>
+          <p:cNvPr id="8" name="txt-201"/>
           <p:cNvSpPr txBox="1"/>
           <p:nvPr/>
         </p:nvSpPr>
@@ -7748,7 +7799,7 @@
       </p:sp>
       <p:sp>
         <p:nvSpPr>
-          <p:cNvPr id="9" name="card-200"/>
+          <p:cNvPr id="9" name="card-202"/>
           <p:cNvSpPr/>
           <p:nvPr/>
         </p:nvSpPr>
@@ -7775,7 +7826,7 @@
       </p:sp>
       <p:sp>
         <p:nvSpPr>
-          <p:cNvPr id="10" name="txt-201"/>
+          <p:cNvPr id="10" name="txt-203"/>
           <p:cNvSpPr txBox="1"/>
           <p:nvPr/>
         </p:nvSpPr>
@@ -7814,7 +7865,7 @@
       </p:sp>
       <p:sp>
         <p:nvSpPr>
-          <p:cNvPr id="11" name="txt-202"/>
+          <p:cNvPr id="11" name="txt-204"/>
           <p:cNvSpPr txBox="1"/>
           <p:nvPr/>
         </p:nvSpPr>
@@ -7853,7 +7904,7 @@
       </p:sp>
       <p:sp>
         <p:nvSpPr>
-          <p:cNvPr id="12" name="card-203"/>
+          <p:cNvPr id="12" name="card-205"/>
           <p:cNvSpPr/>
           <p:nvPr/>
         </p:nvSpPr>
@@ -7880,7 +7931,7 @@
       </p:sp>
       <p:sp>
         <p:nvSpPr>
-          <p:cNvPr id="13" name="txt-204"/>
+          <p:cNvPr id="13" name="txt-206"/>
           <p:cNvSpPr txBox="1"/>
           <p:nvPr/>
         </p:nvSpPr>
@@ -7919,7 +7970,7 @@
       </p:sp>
       <p:sp>
         <p:nvSpPr>
-          <p:cNvPr id="14" name="txt-205"/>
+          <p:cNvPr id="14" name="txt-207"/>
           <p:cNvSpPr txBox="1"/>
           <p:nvPr/>
         </p:nvSpPr>
@@ -7958,7 +8009,7 @@
       </p:sp>
       <p:sp>
         <p:nvSpPr>
-          <p:cNvPr id="15" name="card-206"/>
+          <p:cNvPr id="15" name="card-208"/>
           <p:cNvSpPr/>
           <p:nvPr/>
         </p:nvSpPr>
@@ -7985,7 +8036,7 @@
       </p:sp>
       <p:sp>
         <p:nvSpPr>
-          <p:cNvPr id="16" name="txt-207"/>
+          <p:cNvPr id="16" name="txt-209"/>
           <p:cNvSpPr txBox="1"/>
           <p:nvPr/>
         </p:nvSpPr>
@@ -8024,7 +8075,7 @@
       </p:sp>
       <p:sp>
         <p:nvSpPr>
-          <p:cNvPr id="17" name="txt-208"/>
+          <p:cNvPr id="17" name="txt-210"/>
           <p:cNvSpPr txBox="1"/>
           <p:nvPr/>
         </p:nvSpPr>
@@ -8063,7 +8114,7 @@
       </p:sp>
       <p:sp>
         <p:nvSpPr>
-          <p:cNvPr id="18" name="txt-209"/>
+          <p:cNvPr id="18" name="txt-211"/>
           <p:cNvSpPr txBox="1"/>
           <p:nvPr/>
         </p:nvSpPr>
@@ -8102,7 +8153,7 @@
       </p:sp>
       <p:sp>
         <p:nvSpPr>
-          <p:cNvPr id="19" name="txt-210"/>
+          <p:cNvPr id="19" name="txt-212"/>
           <p:cNvSpPr txBox="1"/>
           <p:nvPr/>
         </p:nvSpPr>
@@ -8357,7 +8408,7 @@
       </p:sp>
       <p:sp>
         <p:nvSpPr>
-          <p:cNvPr id="3" name="card-211"/>
+          <p:cNvPr id="3" name="card-213"/>
           <p:cNvSpPr/>
           <p:nvPr/>
         </p:nvSpPr>
@@ -8384,7 +8435,7 @@
       </p:sp>
       <p:sp>
         <p:nvSpPr>
-          <p:cNvPr id="4" name="dot-212"/>
+          <p:cNvPr id="4" name="dot-214"/>
           <p:cNvSpPr/>
           <p:nvPr/>
         </p:nvSpPr>
@@ -8409,7 +8460,7 @@
       </p:sp>
       <p:sp>
         <p:nvSpPr>
-          <p:cNvPr id="5" name="txt-213"/>
+          <p:cNvPr id="5" name="txt-215"/>
           <p:cNvSpPr txBox="1"/>
           <p:nvPr/>
         </p:nvSpPr>
@@ -8448,7 +8499,7 @@
       </p:sp>
       <p:sp>
         <p:nvSpPr>
-          <p:cNvPr id="6" name="txt-214"/>
+          <p:cNvPr id="6" name="txt-216"/>
           <p:cNvSpPr txBox="1"/>
           <p:nvPr/>
         </p:nvSpPr>
@@ -8487,7 +8538,7 @@
       </p:sp>
       <p:sp>
         <p:nvSpPr>
-          <p:cNvPr id="7" name="txt-215"/>
+          <p:cNvPr id="7" name="txt-217"/>
           <p:cNvSpPr txBox="1"/>
           <p:nvPr/>
         </p:nvSpPr>
@@ -8526,7 +8577,7 @@
       </p:sp>
       <p:sp>
         <p:nvSpPr>
-          <p:cNvPr id="8" name="card-216"/>
+          <p:cNvPr id="8" name="card-218"/>
           <p:cNvSpPr/>
           <p:nvPr/>
         </p:nvSpPr>
@@ -8553,7 +8604,7 @@
       </p:sp>
       <p:sp>
         <p:nvSpPr>
-          <p:cNvPr id="9" name="dot-217"/>
+          <p:cNvPr id="9" name="dot-219"/>
           <p:cNvSpPr/>
           <p:nvPr/>
         </p:nvSpPr>
@@ -8578,7 +8629,7 @@
       </p:sp>
       <p:sp>
         <p:nvSpPr>
-          <p:cNvPr id="10" name="txt-218"/>
+          <p:cNvPr id="10" name="txt-220"/>
           <p:cNvSpPr txBox="1"/>
           <p:nvPr/>
         </p:nvSpPr>
@@ -8617,7 +8668,7 @@
       </p:sp>
       <p:sp>
         <p:nvSpPr>
-          <p:cNvPr id="11" name="txt-219"/>
+          <p:cNvPr id="11" name="txt-221"/>
           <p:cNvSpPr txBox="1"/>
           <p:nvPr/>
         </p:nvSpPr>
@@ -8656,7 +8707,7 @@
       </p:sp>
       <p:sp>
         <p:nvSpPr>
-          <p:cNvPr id="12" name="txt-220"/>
+          <p:cNvPr id="12" name="txt-222"/>
           <p:cNvSpPr txBox="1"/>
           <p:nvPr/>
         </p:nvSpPr>
@@ -8695,7 +8746,7 @@
       </p:sp>
       <p:sp>
         <p:nvSpPr>
-          <p:cNvPr id="13" name="card-221"/>
+          <p:cNvPr id="13" name="card-223"/>
           <p:cNvSpPr/>
           <p:nvPr/>
         </p:nvSpPr>
@@ -8722,7 +8773,7 @@
       </p:sp>
       <p:sp>
         <p:nvSpPr>
-          <p:cNvPr id="14" name="dot-222"/>
+          <p:cNvPr id="14" name="dot-224"/>
           <p:cNvSpPr/>
           <p:nvPr/>
         </p:nvSpPr>
@@ -8747,7 +8798,7 @@
       </p:sp>
       <p:sp>
         <p:nvSpPr>
-          <p:cNvPr id="15" name="txt-223"/>
+          <p:cNvPr id="15" name="txt-225"/>
           <p:cNvSpPr txBox="1"/>
           <p:nvPr/>
         </p:nvSpPr>
@@ -8786,7 +8837,7 @@
       </p:sp>
       <p:sp>
         <p:nvSpPr>
-          <p:cNvPr id="16" name="txt-224"/>
+          <p:cNvPr id="16" name="txt-226"/>
           <p:cNvSpPr txBox="1"/>
           <p:nvPr/>
         </p:nvSpPr>
@@ -8825,7 +8876,7 @@
       </p:sp>
       <p:sp>
         <p:nvSpPr>
-          <p:cNvPr id="17" name="txt-225"/>
+          <p:cNvPr id="17" name="txt-227"/>
           <p:cNvSpPr txBox="1"/>
           <p:nvPr/>
         </p:nvSpPr>
@@ -8864,7 +8915,7 @@
       </p:sp>
       <p:sp>
         <p:nvSpPr>
-          <p:cNvPr id="18" name="card-226"/>
+          <p:cNvPr id="18" name="card-228"/>
           <p:cNvSpPr/>
           <p:nvPr/>
         </p:nvSpPr>
@@ -8891,7 +8942,7 @@
       </p:sp>
       <p:sp>
         <p:nvSpPr>
-          <p:cNvPr id="19" name="dot-227"/>
+          <p:cNvPr id="19" name="dot-229"/>
           <p:cNvSpPr/>
           <p:nvPr/>
         </p:nvSpPr>
@@ -8916,7 +8967,7 @@
       </p:sp>
       <p:sp>
         <p:nvSpPr>
-          <p:cNvPr id="20" name="txt-228"/>
+          <p:cNvPr id="20" name="txt-230"/>
           <p:cNvSpPr txBox="1"/>
           <p:nvPr/>
         </p:nvSpPr>
@@ -8955,7 +9006,7 @@
       </p:sp>
       <p:sp>
         <p:nvSpPr>
-          <p:cNvPr id="21" name="txt-229"/>
+          <p:cNvPr id="21" name="txt-231"/>
           <p:cNvSpPr txBox="1"/>
           <p:nvPr/>
         </p:nvSpPr>
@@ -8994,7 +9045,7 @@
       </p:sp>
       <p:sp>
         <p:nvSpPr>
-          <p:cNvPr id="22" name="txt-230"/>
+          <p:cNvPr id="22" name="txt-232"/>
           <p:cNvSpPr txBox="1"/>
           <p:nvPr/>
         </p:nvSpPr>
@@ -9141,7 +9192,7 @@
       </p:sp>
       <p:sp>
         <p:nvSpPr>
-          <p:cNvPr id="3" name="txt-231"/>
+          <p:cNvPr id="3" name="txt-233"/>
           <p:cNvSpPr txBox="1"/>
           <p:nvPr/>
         </p:nvSpPr>
@@ -9267,7 +9318,7 @@
       </p:sp>
       <p:sp>
         <p:nvSpPr>
-          <p:cNvPr id="4" name="txt-232"/>
+          <p:cNvPr id="4" name="txt-234"/>
           <p:cNvSpPr txBox="1"/>
           <p:nvPr/>
         </p:nvSpPr>
@@ -9560,7 +9611,7 @@
       </p:sp>
       <p:sp>
         <p:nvSpPr>
-          <p:cNvPr id="4" name="dot-233"/>
+          <p:cNvPr id="4" name="dot-235"/>
           <p:cNvSpPr/>
           <p:nvPr/>
         </p:nvSpPr>
@@ -9585,7 +9636,7 @@
       </p:sp>
       <p:sp>
         <p:nvSpPr>
-          <p:cNvPr id="5" name="txt-234"/>
+          <p:cNvPr id="5" name="txt-236"/>
           <p:cNvSpPr txBox="1"/>
           <p:nvPr/>
         </p:nvSpPr>
@@ -9687,7 +9738,7 @@
       </p:sp>
       <p:sp>
         <p:nvSpPr>
-          <p:cNvPr id="3" name="txt-5"/>
+          <p:cNvPr id="3" name="txt-7"/>
           <p:cNvSpPr txBox="1"/>
           <p:nvPr/>
         </p:nvSpPr>
@@ -9726,7 +9777,7 @@
       </p:sp>
       <p:sp>
         <p:nvSpPr>
-          <p:cNvPr id="4" name="txt-6"/>
+          <p:cNvPr id="4" name="txt-8"/>
           <p:cNvSpPr txBox="1"/>
           <p:nvPr/>
         </p:nvSpPr>
@@ -9765,7 +9816,7 @@
       </p:sp>
       <p:sp>
         <p:nvSpPr>
-          <p:cNvPr id="5" name="txt-7"/>
+          <p:cNvPr id="5" name="txt-9"/>
           <p:cNvSpPr txBox="1"/>
           <p:nvPr/>
         </p:nvSpPr>
@@ -9804,7 +9855,7 @@
       </p:sp>
       <p:sp>
         <p:nvSpPr>
-          <p:cNvPr id="6" name="txt-8"/>
+          <p:cNvPr id="6" name="txt-10"/>
           <p:cNvSpPr txBox="1"/>
           <p:nvPr/>
         </p:nvSpPr>
@@ -9843,7 +9894,7 @@
       </p:sp>
       <p:sp>
         <p:nvSpPr>
-          <p:cNvPr id="7" name="txt-9"/>
+          <p:cNvPr id="7" name="txt-11"/>
           <p:cNvSpPr txBox="1"/>
           <p:nvPr/>
         </p:nvSpPr>
@@ -9882,7 +9933,7 @@
       </p:sp>
       <p:sp>
         <p:nvSpPr>
-          <p:cNvPr id="8" name="txt-10"/>
+          <p:cNvPr id="8" name="txt-12"/>
           <p:cNvSpPr txBox="1"/>
           <p:nvPr/>
         </p:nvSpPr>
@@ -9921,7 +9972,7 @@
       </p:sp>
       <p:sp>
         <p:nvSpPr>
-          <p:cNvPr id="9" name="card-11"/>
+          <p:cNvPr id="9" name="card-13"/>
           <p:cNvSpPr/>
           <p:nvPr/>
         </p:nvSpPr>
@@ -9948,7 +9999,7 @@
       </p:sp>
       <p:sp>
         <p:nvSpPr>
-          <p:cNvPr id="10" name="txt-12"/>
+          <p:cNvPr id="10" name="txt-14"/>
           <p:cNvSpPr txBox="1"/>
           <p:nvPr/>
         </p:nvSpPr>
@@ -10182,7 +10233,7 @@
       </p:sp>
       <p:sp>
         <p:nvSpPr>
-          <p:cNvPr id="3" name="card-13"/>
+          <p:cNvPr id="3" name="card-15"/>
           <p:cNvSpPr/>
           <p:nvPr/>
         </p:nvSpPr>
@@ -10209,7 +10260,7 @@
       </p:sp>
       <p:sp>
         <p:nvSpPr>
-          <p:cNvPr id="4" name="dot-14"/>
+          <p:cNvPr id="4" name="dot-16"/>
           <p:cNvSpPr/>
           <p:nvPr/>
         </p:nvSpPr>
@@ -10234,7 +10285,7 @@
       </p:sp>
       <p:sp>
         <p:nvSpPr>
-          <p:cNvPr id="5" name="txt-15"/>
+          <p:cNvPr id="5" name="txt-17"/>
           <p:cNvSpPr txBox="1"/>
           <p:nvPr/>
         </p:nvSpPr>
@@ -10273,7 +10324,7 @@
       </p:sp>
       <p:sp>
         <p:nvSpPr>
-          <p:cNvPr id="6" name="txt-16"/>
+          <p:cNvPr id="6" name="txt-18"/>
           <p:cNvSpPr txBox="1"/>
           <p:nvPr/>
         </p:nvSpPr>
@@ -10312,7 +10363,7 @@
       </p:sp>
       <p:sp>
         <p:nvSpPr>
-          <p:cNvPr id="7" name="txt-17"/>
+          <p:cNvPr id="7" name="txt-19"/>
           <p:cNvSpPr txBox="1"/>
           <p:nvPr/>
         </p:nvSpPr>
@@ -10351,7 +10402,7 @@
       </p:sp>
       <p:sp>
         <p:nvSpPr>
-          <p:cNvPr id="8" name="card-18"/>
+          <p:cNvPr id="8" name="card-20"/>
           <p:cNvSpPr/>
           <p:nvPr/>
         </p:nvSpPr>
@@ -10378,7 +10429,7 @@
       </p:sp>
       <p:sp>
         <p:nvSpPr>
-          <p:cNvPr id="9" name="dot-19"/>
+          <p:cNvPr id="9" name="dot-21"/>
           <p:cNvSpPr/>
           <p:nvPr/>
         </p:nvSpPr>
@@ -10403,7 +10454,7 @@
       </p:sp>
       <p:sp>
         <p:nvSpPr>
-          <p:cNvPr id="10" name="txt-20"/>
+          <p:cNvPr id="10" name="txt-22"/>
           <p:cNvSpPr txBox="1"/>
           <p:nvPr/>
         </p:nvSpPr>
@@ -10442,7 +10493,7 @@
       </p:sp>
       <p:sp>
         <p:nvSpPr>
-          <p:cNvPr id="11" name="txt-21"/>
+          <p:cNvPr id="11" name="txt-23"/>
           <p:cNvSpPr txBox="1"/>
           <p:nvPr/>
         </p:nvSpPr>
@@ -10481,7 +10532,7 @@
       </p:sp>
       <p:sp>
         <p:nvSpPr>
-          <p:cNvPr id="12" name="txt-22"/>
+          <p:cNvPr id="12" name="txt-24"/>
           <p:cNvSpPr txBox="1"/>
           <p:nvPr/>
         </p:nvSpPr>
@@ -10520,7 +10571,7 @@
       </p:sp>
       <p:sp>
         <p:nvSpPr>
-          <p:cNvPr id="13" name="card-23"/>
+          <p:cNvPr id="13" name="card-25"/>
           <p:cNvSpPr/>
           <p:nvPr/>
         </p:nvSpPr>
@@ -10547,7 +10598,7 @@
       </p:sp>
       <p:sp>
         <p:nvSpPr>
-          <p:cNvPr id="14" name="dot-24"/>
+          <p:cNvPr id="14" name="dot-26"/>
           <p:cNvSpPr/>
           <p:nvPr/>
         </p:nvSpPr>
@@ -10572,7 +10623,7 @@
       </p:sp>
       <p:sp>
         <p:nvSpPr>
-          <p:cNvPr id="15" name="txt-25"/>
+          <p:cNvPr id="15" name="txt-27"/>
           <p:cNvSpPr txBox="1"/>
           <p:nvPr/>
         </p:nvSpPr>
@@ -10611,7 +10662,7 @@
       </p:sp>
       <p:sp>
         <p:nvSpPr>
-          <p:cNvPr id="16" name="txt-26"/>
+          <p:cNvPr id="16" name="txt-28"/>
           <p:cNvSpPr txBox="1"/>
           <p:nvPr/>
         </p:nvSpPr>
@@ -10650,7 +10701,7 @@
       </p:sp>
       <p:sp>
         <p:nvSpPr>
-          <p:cNvPr id="17" name="txt-27"/>
+          <p:cNvPr id="17" name="txt-29"/>
           <p:cNvSpPr txBox="1"/>
           <p:nvPr/>
         </p:nvSpPr>
@@ -10689,7 +10740,7 @@
       </p:sp>
       <p:sp>
         <p:nvSpPr>
-          <p:cNvPr id="18" name="card-28"/>
+          <p:cNvPr id="18" name="card-30"/>
           <p:cNvSpPr/>
           <p:nvPr/>
         </p:nvSpPr>
@@ -10716,7 +10767,7 @@
       </p:sp>
       <p:sp>
         <p:nvSpPr>
-          <p:cNvPr id="19" name="dot-29"/>
+          <p:cNvPr id="19" name="dot-31"/>
           <p:cNvSpPr/>
           <p:nvPr/>
         </p:nvSpPr>
@@ -10741,7 +10792,7 @@
       </p:sp>
       <p:sp>
         <p:nvSpPr>
-          <p:cNvPr id="20" name="txt-30"/>
+          <p:cNvPr id="20" name="txt-32"/>
           <p:cNvSpPr txBox="1"/>
           <p:nvPr/>
         </p:nvSpPr>
@@ -10780,7 +10831,7 @@
       </p:sp>
       <p:sp>
         <p:nvSpPr>
-          <p:cNvPr id="21" name="txt-31"/>
+          <p:cNvPr id="21" name="txt-33"/>
           <p:cNvSpPr txBox="1"/>
           <p:nvPr/>
         </p:nvSpPr>
@@ -10819,7 +10870,7 @@
       </p:sp>
       <p:sp>
         <p:nvSpPr>
-          <p:cNvPr id="22" name="txt-32"/>
+          <p:cNvPr id="22" name="txt-34"/>
           <p:cNvSpPr txBox="1"/>
           <p:nvPr/>
         </p:nvSpPr>
@@ -10858,7 +10909,7 @@
       </p:sp>
       <p:sp>
         <p:nvSpPr>
-          <p:cNvPr id="23" name="card-33"/>
+          <p:cNvPr id="23" name="card-35"/>
           <p:cNvSpPr/>
           <p:nvPr/>
         </p:nvSpPr>
@@ -10885,7 +10936,7 @@
       </p:sp>
       <p:sp>
         <p:nvSpPr>
-          <p:cNvPr id="24" name="dot-34"/>
+          <p:cNvPr id="24" name="dot-36"/>
           <p:cNvSpPr/>
           <p:nvPr/>
         </p:nvSpPr>
@@ -10910,7 +10961,7 @@
       </p:sp>
       <p:sp>
         <p:nvSpPr>
-          <p:cNvPr id="25" name="txt-35"/>
+          <p:cNvPr id="25" name="txt-37"/>
           <p:cNvSpPr txBox="1"/>
           <p:nvPr/>
         </p:nvSpPr>
@@ -10949,7 +11000,7 @@
       </p:sp>
       <p:sp>
         <p:nvSpPr>
-          <p:cNvPr id="26" name="txt-36"/>
+          <p:cNvPr id="26" name="txt-38"/>
           <p:cNvSpPr txBox="1"/>
           <p:nvPr/>
         </p:nvSpPr>
@@ -10988,7 +11039,7 @@
       </p:sp>
       <p:sp>
         <p:nvSpPr>
-          <p:cNvPr id="27" name="txt-37"/>
+          <p:cNvPr id="27" name="txt-39"/>
           <p:cNvSpPr txBox="1"/>
           <p:nvPr/>
         </p:nvSpPr>
@@ -11027,7 +11078,7 @@
       </p:sp>
       <p:sp>
         <p:nvSpPr>
-          <p:cNvPr id="28" name="card-38"/>
+          <p:cNvPr id="28" name="card-40"/>
           <p:cNvSpPr/>
           <p:nvPr/>
         </p:nvSpPr>
@@ -11054,7 +11105,7 @@
       </p:sp>
       <p:sp>
         <p:nvSpPr>
-          <p:cNvPr id="29" name="dot-39"/>
+          <p:cNvPr id="29" name="dot-41"/>
           <p:cNvSpPr/>
           <p:nvPr/>
         </p:nvSpPr>
@@ -11079,7 +11130,7 @@
       </p:sp>
       <p:sp>
         <p:nvSpPr>
-          <p:cNvPr id="30" name="txt-40"/>
+          <p:cNvPr id="30" name="txt-42"/>
           <p:cNvSpPr txBox="1"/>
           <p:nvPr/>
         </p:nvSpPr>
@@ -11118,7 +11169,7 @@
       </p:sp>
       <p:sp>
         <p:nvSpPr>
-          <p:cNvPr id="31" name="txt-41"/>
+          <p:cNvPr id="31" name="txt-43"/>
           <p:cNvSpPr txBox="1"/>
           <p:nvPr/>
         </p:nvSpPr>
@@ -11157,7 +11208,7 @@
       </p:sp>
       <p:sp>
         <p:nvSpPr>
-          <p:cNvPr id="32" name="txt-42"/>
+          <p:cNvPr id="32" name="txt-44"/>
           <p:cNvSpPr txBox="1"/>
           <p:nvPr/>
         </p:nvSpPr>
@@ -11304,7 +11355,7 @@
       </p:sp>
       <p:sp>
         <p:nvSpPr>
-          <p:cNvPr id="3" name="card-43"/>
+          <p:cNvPr id="3" name="card-45"/>
           <p:cNvSpPr/>
           <p:nvPr/>
         </p:nvSpPr>
@@ -11331,7 +11382,7 @@
       </p:sp>
       <p:sp>
         <p:nvSpPr>
-          <p:cNvPr id="4" name="txt-44"/>
+          <p:cNvPr id="4" name="txt-46"/>
           <p:cNvSpPr txBox="1"/>
           <p:nvPr/>
         </p:nvSpPr>
@@ -11370,7 +11421,7 @@
       </p:sp>
       <p:sp>
         <p:nvSpPr>
-          <p:cNvPr id="5" name="txt-45"/>
+          <p:cNvPr id="5" name="txt-47"/>
           <p:cNvSpPr txBox="1"/>
           <p:nvPr/>
         </p:nvSpPr>
@@ -11409,7 +11460,7 @@
       </p:sp>
       <p:sp>
         <p:nvSpPr>
-          <p:cNvPr id="6" name="txt-46"/>
+          <p:cNvPr id="6" name="txt-48"/>
           <p:cNvSpPr txBox="1"/>
           <p:nvPr/>
         </p:nvSpPr>
@@ -11448,7 +11499,7 @@
       </p:sp>
       <p:sp>
         <p:nvSpPr>
-          <p:cNvPr id="7" name="card-47"/>
+          <p:cNvPr id="7" name="card-49"/>
           <p:cNvSpPr/>
           <p:nvPr/>
         </p:nvSpPr>
@@ -11475,7 +11526,7 @@
       </p:sp>
       <p:sp>
         <p:nvSpPr>
-          <p:cNvPr id="8" name="txt-48"/>
+          <p:cNvPr id="8" name="txt-50"/>
           <p:cNvSpPr txBox="1"/>
           <p:nvPr/>
         </p:nvSpPr>
@@ -11514,7 +11565,7 @@
       </p:sp>
       <p:sp>
         <p:nvSpPr>
-          <p:cNvPr id="9" name="txt-49"/>
+          <p:cNvPr id="9" name="txt-51"/>
           <p:cNvSpPr txBox="1"/>
           <p:nvPr/>
         </p:nvSpPr>
@@ -11553,7 +11604,7 @@
       </p:sp>
       <p:sp>
         <p:nvSpPr>
-          <p:cNvPr id="10" name="txt-50"/>
+          <p:cNvPr id="10" name="txt-52"/>
           <p:cNvSpPr txBox="1"/>
           <p:nvPr/>
         </p:nvSpPr>
@@ -11592,7 +11643,7 @@
       </p:sp>
       <p:sp>
         <p:nvSpPr>
-          <p:cNvPr id="11" name="card-51"/>
+          <p:cNvPr id="11" name="card-53"/>
           <p:cNvSpPr/>
           <p:nvPr/>
         </p:nvSpPr>
@@ -11619,7 +11670,7 @@
       </p:sp>
       <p:sp>
         <p:nvSpPr>
-          <p:cNvPr id="12" name="txt-52"/>
+          <p:cNvPr id="12" name="txt-54"/>
           <p:cNvSpPr txBox="1"/>
           <p:nvPr/>
         </p:nvSpPr>
@@ -11658,7 +11709,7 @@
       </p:sp>
       <p:sp>
         <p:nvSpPr>
-          <p:cNvPr id="13" name="txt-53"/>
+          <p:cNvPr id="13" name="txt-55"/>
           <p:cNvSpPr txBox="1"/>
           <p:nvPr/>
         </p:nvSpPr>
@@ -11697,7 +11748,7 @@
       </p:sp>
       <p:sp>
         <p:nvSpPr>
-          <p:cNvPr id="14" name="txt-54"/>
+          <p:cNvPr id="14" name="txt-56"/>
           <p:cNvSpPr txBox="1"/>
           <p:nvPr/>
         </p:nvSpPr>
@@ -11736,7 +11787,7 @@
       </p:sp>
       <p:sp>
         <p:nvSpPr>
-          <p:cNvPr id="15" name="card-55"/>
+          <p:cNvPr id="15" name="card-57"/>
           <p:cNvSpPr/>
           <p:nvPr/>
         </p:nvSpPr>
@@ -11763,7 +11814,7 @@
       </p:sp>
       <p:sp>
         <p:nvSpPr>
-          <p:cNvPr id="16" name="txt-56"/>
+          <p:cNvPr id="16" name="txt-58"/>
           <p:cNvSpPr txBox="1"/>
           <p:nvPr/>
         </p:nvSpPr>
@@ -11802,7 +11853,7 @@
       </p:sp>
       <p:sp>
         <p:nvSpPr>
-          <p:cNvPr id="17" name="txt-57"/>
+          <p:cNvPr id="17" name="txt-59"/>
           <p:cNvSpPr txBox="1"/>
           <p:nvPr/>
         </p:nvSpPr>
@@ -11841,7 +11892,7 @@
       </p:sp>
       <p:sp>
         <p:nvSpPr>
-          <p:cNvPr id="18" name="txt-58"/>
+          <p:cNvPr id="18" name="txt-60"/>
           <p:cNvSpPr txBox="1"/>
           <p:nvPr/>
         </p:nvSpPr>
@@ -11988,7 +12039,7 @@
       </p:sp>
       <p:sp>
         <p:nvSpPr>
-          <p:cNvPr id="3" name="card-59"/>
+          <p:cNvPr id="3" name="card-61"/>
           <p:cNvSpPr/>
           <p:nvPr/>
         </p:nvSpPr>
@@ -12015,7 +12066,7 @@
       </p:sp>
       <p:sp>
         <p:nvSpPr>
-          <p:cNvPr id="4" name="dot-60"/>
+          <p:cNvPr id="4" name="dot-62"/>
           <p:cNvSpPr/>
           <p:nvPr/>
         </p:nvSpPr>
@@ -12040,7 +12091,7 @@
       </p:sp>
       <p:sp>
         <p:nvSpPr>
-          <p:cNvPr id="5" name="txt-61"/>
+          <p:cNvPr id="5" name="txt-63"/>
           <p:cNvSpPr txBox="1"/>
           <p:nvPr/>
         </p:nvSpPr>
@@ -12079,7 +12130,7 @@
       </p:sp>
       <p:sp>
         <p:nvSpPr>
-          <p:cNvPr id="6" name="txt-62"/>
+          <p:cNvPr id="6" name="txt-64"/>
           <p:cNvSpPr txBox="1"/>
           <p:nvPr/>
         </p:nvSpPr>
@@ -12118,7 +12169,7 @@
       </p:sp>
       <p:sp>
         <p:nvSpPr>
-          <p:cNvPr id="7" name="txt-63"/>
+          <p:cNvPr id="7" name="txt-65"/>
           <p:cNvSpPr txBox="1"/>
           <p:nvPr/>
         </p:nvSpPr>
@@ -12157,7 +12208,7 @@
       </p:sp>
       <p:sp>
         <p:nvSpPr>
-          <p:cNvPr id="8" name="txt-64"/>
+          <p:cNvPr id="8" name="txt-66"/>
           <p:cNvSpPr txBox="1"/>
           <p:nvPr/>
         </p:nvSpPr>
@@ -12196,7 +12247,7 @@
       </p:sp>
       <p:sp>
         <p:nvSpPr>
-          <p:cNvPr id="9" name="card-65"/>
+          <p:cNvPr id="9" name="card-67"/>
           <p:cNvSpPr/>
           <p:nvPr/>
         </p:nvSpPr>
@@ -12223,7 +12274,7 @@
       </p:sp>
       <p:sp>
         <p:nvSpPr>
-          <p:cNvPr id="10" name="dot-66"/>
+          <p:cNvPr id="10" name="dot-68"/>
           <p:cNvSpPr/>
           <p:nvPr/>
         </p:nvSpPr>
@@ -12248,7 +12299,7 @@
       </p:sp>
       <p:sp>
         <p:nvSpPr>
-          <p:cNvPr id="11" name="txt-67"/>
+          <p:cNvPr id="11" name="txt-69"/>
           <p:cNvSpPr txBox="1"/>
           <p:nvPr/>
         </p:nvSpPr>
@@ -12287,7 +12338,7 @@
       </p:sp>
       <p:sp>
         <p:nvSpPr>
-          <p:cNvPr id="12" name="txt-68"/>
+          <p:cNvPr id="12" name="txt-70"/>
           <p:cNvSpPr txBox="1"/>
           <p:nvPr/>
         </p:nvSpPr>
@@ -12326,7 +12377,7 @@
       </p:sp>
       <p:sp>
         <p:nvSpPr>
-          <p:cNvPr id="13" name="txt-69"/>
+          <p:cNvPr id="13" name="txt-71"/>
           <p:cNvSpPr txBox="1"/>
           <p:nvPr/>
         </p:nvSpPr>
@@ -12365,7 +12416,7 @@
       </p:sp>
       <p:sp>
         <p:nvSpPr>
-          <p:cNvPr id="14" name="txt-70"/>
+          <p:cNvPr id="14" name="txt-72"/>
           <p:cNvSpPr txBox="1"/>
           <p:nvPr/>
         </p:nvSpPr>
@@ -12404,7 +12455,7 @@
       </p:sp>
       <p:sp>
         <p:nvSpPr>
-          <p:cNvPr id="15" name="card-71"/>
+          <p:cNvPr id="15" name="card-73"/>
           <p:cNvSpPr/>
           <p:nvPr/>
         </p:nvSpPr>
@@ -12431,7 +12482,7 @@
       </p:sp>
       <p:sp>
         <p:nvSpPr>
-          <p:cNvPr id="16" name="dot-72"/>
+          <p:cNvPr id="16" name="dot-74"/>
           <p:cNvSpPr/>
           <p:nvPr/>
         </p:nvSpPr>
@@ -12456,7 +12507,7 @@
       </p:sp>
       <p:sp>
         <p:nvSpPr>
-          <p:cNvPr id="17" name="txt-73"/>
+          <p:cNvPr id="17" name="txt-75"/>
           <p:cNvSpPr txBox="1"/>
           <p:nvPr/>
         </p:nvSpPr>
@@ -12495,7 +12546,7 @@
       </p:sp>
       <p:sp>
         <p:nvSpPr>
-          <p:cNvPr id="18" name="txt-74"/>
+          <p:cNvPr id="18" name="txt-76"/>
           <p:cNvSpPr txBox="1"/>
           <p:nvPr/>
         </p:nvSpPr>
@@ -12534,7 +12585,7 @@
       </p:sp>
       <p:sp>
         <p:nvSpPr>
-          <p:cNvPr id="19" name="txt-75"/>
+          <p:cNvPr id="19" name="txt-77"/>
           <p:cNvSpPr txBox="1"/>
           <p:nvPr/>
         </p:nvSpPr>
@@ -12573,7 +12624,7 @@
       </p:sp>
       <p:sp>
         <p:nvSpPr>
-          <p:cNvPr id="20" name="txt-76"/>
+          <p:cNvPr id="20" name="txt-78"/>
           <p:cNvSpPr txBox="1"/>
           <p:nvPr/>
         </p:nvSpPr>
@@ -12612,7 +12663,7 @@
       </p:sp>
       <p:sp>
         <p:nvSpPr>
-          <p:cNvPr id="21" name="txt-77"/>
+          <p:cNvPr id="21" name="txt-79"/>
           <p:cNvSpPr txBox="1"/>
           <p:nvPr/>
         </p:nvSpPr>
@@ -12759,7 +12810,7 @@
       </p:sp>
       <p:sp>
         <p:nvSpPr>
-          <p:cNvPr id="3" name="card-78"/>
+          <p:cNvPr id="3" name="card-80"/>
           <p:cNvSpPr/>
           <p:nvPr/>
         </p:nvSpPr>
@@ -12786,7 +12837,7 @@
       </p:sp>
       <p:sp>
         <p:nvSpPr>
-          <p:cNvPr id="4" name="txt-79"/>
+          <p:cNvPr id="4" name="txt-81"/>
           <p:cNvSpPr txBox="1"/>
           <p:nvPr/>
         </p:nvSpPr>
@@ -12825,7 +12876,7 @@
       </p:sp>
       <p:sp>
         <p:nvSpPr>
-          <p:cNvPr id="5" name="txt-80"/>
+          <p:cNvPr id="5" name="txt-82"/>
           <p:cNvSpPr txBox="1"/>
           <p:nvPr/>
         </p:nvSpPr>
@@ -12864,7 +12915,7 @@
       </p:sp>
       <p:sp>
         <p:nvSpPr>
-          <p:cNvPr id="6" name="txt-81"/>
+          <p:cNvPr id="6" name="txt-83"/>
           <p:cNvSpPr txBox="1"/>
           <p:nvPr/>
         </p:nvSpPr>
@@ -12903,7 +12954,7 @@
       </p:sp>
       <p:sp>
         <p:nvSpPr>
-          <p:cNvPr id="7" name="card-82"/>
+          <p:cNvPr id="7" name="card-84"/>
           <p:cNvSpPr/>
           <p:nvPr/>
         </p:nvSpPr>
@@ -12930,7 +12981,7 @@
       </p:sp>
       <p:sp>
         <p:nvSpPr>
-          <p:cNvPr id="8" name="txt-83"/>
+          <p:cNvPr id="8" name="txt-85"/>
           <p:cNvSpPr txBox="1"/>
           <p:nvPr/>
         </p:nvSpPr>
@@ -12969,7 +13020,7 @@
       </p:sp>
       <p:sp>
         <p:nvSpPr>
-          <p:cNvPr id="9" name="txt-84"/>
+          <p:cNvPr id="9" name="txt-86"/>
           <p:cNvSpPr txBox="1"/>
           <p:nvPr/>
         </p:nvSpPr>
@@ -13008,7 +13059,7 @@
       </p:sp>
       <p:sp>
         <p:nvSpPr>
-          <p:cNvPr id="10" name="txt-85"/>
+          <p:cNvPr id="10" name="txt-87"/>
           <p:cNvSpPr txBox="1"/>
           <p:nvPr/>
         </p:nvSpPr>
@@ -13047,7 +13098,7 @@
       </p:sp>
       <p:sp>
         <p:nvSpPr>
-          <p:cNvPr id="11" name="card-86"/>
+          <p:cNvPr id="11" name="card-88"/>
           <p:cNvSpPr/>
           <p:nvPr/>
         </p:nvSpPr>
@@ -13074,7 +13125,7 @@
       </p:sp>
       <p:sp>
         <p:nvSpPr>
-          <p:cNvPr id="12" name="txt-87"/>
+          <p:cNvPr id="12" name="txt-89"/>
           <p:cNvSpPr txBox="1"/>
           <p:nvPr/>
         </p:nvSpPr>
@@ -13113,7 +13164,7 @@
       </p:sp>
       <p:sp>
         <p:nvSpPr>
-          <p:cNvPr id="13" name="txt-88"/>
+          <p:cNvPr id="13" name="txt-90"/>
           <p:cNvSpPr txBox="1"/>
           <p:nvPr/>
         </p:nvSpPr>
@@ -13152,7 +13203,7 @@
       </p:sp>
       <p:sp>
         <p:nvSpPr>
-          <p:cNvPr id="14" name="txt-89"/>
+          <p:cNvPr id="14" name="txt-91"/>
           <p:cNvSpPr txBox="1"/>
           <p:nvPr/>
         </p:nvSpPr>
@@ -13191,7 +13242,7 @@
       </p:sp>
       <p:sp>
         <p:nvSpPr>
-          <p:cNvPr id="15" name="card-90"/>
+          <p:cNvPr id="15" name="card-92"/>
           <p:cNvSpPr/>
           <p:nvPr/>
         </p:nvSpPr>
@@ -13218,7 +13269,7 @@
       </p:sp>
       <p:sp>
         <p:nvSpPr>
-          <p:cNvPr id="16" name="txt-91"/>
+          <p:cNvPr id="16" name="txt-93"/>
           <p:cNvSpPr txBox="1"/>
           <p:nvPr/>
         </p:nvSpPr>
@@ -13257,7 +13308,7 @@
       </p:sp>
       <p:sp>
         <p:nvSpPr>
-          <p:cNvPr id="17" name="txt-92"/>
+          <p:cNvPr id="17" name="txt-94"/>
           <p:cNvSpPr txBox="1"/>
           <p:nvPr/>
         </p:nvSpPr>
@@ -13296,7 +13347,7 @@
       </p:sp>
       <p:sp>
         <p:nvSpPr>
-          <p:cNvPr id="18" name="txt-93"/>
+          <p:cNvPr id="18" name="txt-95"/>
           <p:cNvSpPr txBox="1"/>
           <p:nvPr/>
         </p:nvSpPr>
@@ -13335,7 +13386,7 @@
       </p:sp>
       <p:sp>
         <p:nvSpPr>
-          <p:cNvPr id="19" name="card-94"/>
+          <p:cNvPr id="19" name="card-96"/>
           <p:cNvSpPr/>
           <p:nvPr/>
         </p:nvSpPr>
@@ -13362,7 +13413,7 @@
       </p:sp>
       <p:sp>
         <p:nvSpPr>
-          <p:cNvPr id="20" name="txt-95"/>
+          <p:cNvPr id="20" name="txt-97"/>
           <p:cNvSpPr txBox="1"/>
           <p:nvPr/>
         </p:nvSpPr>
@@ -13401,7 +13452,7 @@
       </p:sp>
       <p:sp>
         <p:nvSpPr>
-          <p:cNvPr id="21" name="txt-96"/>
+          <p:cNvPr id="21" name="txt-98"/>
           <p:cNvSpPr txBox="1"/>
           <p:nvPr/>
         </p:nvSpPr>
@@ -13440,7 +13491,7 @@
       </p:sp>
       <p:sp>
         <p:nvSpPr>
-          <p:cNvPr id="22" name="txt-97"/>
+          <p:cNvPr id="22" name="txt-99"/>
           <p:cNvSpPr txBox="1"/>
           <p:nvPr/>
         </p:nvSpPr>
@@ -13479,7 +13530,7 @@
       </p:sp>
       <p:sp>
         <p:nvSpPr>
-          <p:cNvPr id="23" name="card-98"/>
+          <p:cNvPr id="23" name="card-100"/>
           <p:cNvSpPr/>
           <p:nvPr/>
         </p:nvSpPr>
@@ -13506,7 +13557,7 @@
       </p:sp>
       <p:sp>
         <p:nvSpPr>
-          <p:cNvPr id="24" name="txt-99"/>
+          <p:cNvPr id="24" name="txt-101"/>
           <p:cNvSpPr txBox="1"/>
           <p:nvPr/>
         </p:nvSpPr>
@@ -13545,7 +13596,7 @@
       </p:sp>
       <p:sp>
         <p:nvSpPr>
-          <p:cNvPr id="25" name="txt-100"/>
+          <p:cNvPr id="25" name="txt-102"/>
           <p:cNvSpPr txBox="1"/>
           <p:nvPr/>
         </p:nvSpPr>
@@ -13584,7 +13635,7 @@
       </p:sp>
       <p:sp>
         <p:nvSpPr>
-          <p:cNvPr id="26" name="txt-101"/>
+          <p:cNvPr id="26" name="txt-103"/>
           <p:cNvSpPr txBox="1"/>
           <p:nvPr/>
         </p:nvSpPr>
@@ -13623,7 +13674,7 @@
       </p:sp>
       <p:sp>
         <p:nvSpPr>
-          <p:cNvPr id="27" name="card-102"/>
+          <p:cNvPr id="27" name="card-104"/>
           <p:cNvSpPr/>
           <p:nvPr/>
         </p:nvSpPr>
@@ -13650,7 +13701,7 @@
       </p:sp>
       <p:sp>
         <p:nvSpPr>
-          <p:cNvPr id="28" name="txt-103"/>
+          <p:cNvPr id="28" name="txt-105"/>
           <p:cNvSpPr txBox="1"/>
           <p:nvPr/>
         </p:nvSpPr>
@@ -13689,7 +13740,7 @@
       </p:sp>
       <p:sp>
         <p:nvSpPr>
-          <p:cNvPr id="29" name="txt-104"/>
+          <p:cNvPr id="29" name="txt-106"/>
           <p:cNvSpPr txBox="1"/>
           <p:nvPr/>
         </p:nvSpPr>
@@ -13728,7 +13779,7 @@
       </p:sp>
       <p:sp>
         <p:nvSpPr>
-          <p:cNvPr id="30" name="txt-105"/>
+          <p:cNvPr id="30" name="txt-107"/>
           <p:cNvSpPr txBox="1"/>
           <p:nvPr/>
         </p:nvSpPr>
@@ -13767,7 +13818,7 @@
       </p:sp>
       <p:sp>
         <p:nvSpPr>
-          <p:cNvPr id="31" name="card-106"/>
+          <p:cNvPr id="31" name="card-108"/>
           <p:cNvSpPr/>
           <p:nvPr/>
         </p:nvSpPr>
@@ -13794,7 +13845,7 @@
       </p:sp>
       <p:sp>
         <p:nvSpPr>
-          <p:cNvPr id="32" name="txt-107"/>
+          <p:cNvPr id="32" name="txt-109"/>
           <p:cNvSpPr txBox="1"/>
           <p:nvPr/>
         </p:nvSpPr>
@@ -13833,7 +13884,7 @@
       </p:sp>
       <p:sp>
         <p:nvSpPr>
-          <p:cNvPr id="33" name="txt-108"/>
+          <p:cNvPr id="33" name="txt-110"/>
           <p:cNvSpPr txBox="1"/>
           <p:nvPr/>
         </p:nvSpPr>
@@ -13872,7 +13923,7 @@
       </p:sp>
       <p:sp>
         <p:nvSpPr>
-          <p:cNvPr id="34" name="txt-109"/>
+          <p:cNvPr id="34" name="txt-111"/>
           <p:cNvSpPr txBox="1"/>
           <p:nvPr/>
         </p:nvSpPr>
@@ -13911,7 +13962,7 @@
       </p:sp>
       <p:sp>
         <p:nvSpPr>
-          <p:cNvPr id="35" name="txt-110"/>
+          <p:cNvPr id="35" name="txt-112"/>
           <p:cNvSpPr txBox="1"/>
           <p:nvPr/>
         </p:nvSpPr>
@@ -13950,7 +14001,7 @@
       </p:sp>
       <p:sp>
         <p:nvSpPr>
-          <p:cNvPr id="36" name="step-111"/>
+          <p:cNvPr id="36" name="step-113"/>
           <p:cNvSpPr/>
           <p:nvPr/>
         </p:nvSpPr>
@@ -13977,7 +14028,7 @@
       </p:sp>
       <p:sp>
         <p:nvSpPr>
-          <p:cNvPr id="37" name="txt-112"/>
+          <p:cNvPr id="37" name="txt-114"/>
           <p:cNvSpPr txBox="1"/>
           <p:nvPr/>
         </p:nvSpPr>
@@ -14016,7 +14067,7 @@
       </p:sp>
       <p:sp>
         <p:nvSpPr>
-          <p:cNvPr id="38" name="txt-113"/>
+          <p:cNvPr id="38" name="txt-115"/>
           <p:cNvSpPr txBox="1"/>
           <p:nvPr/>
         </p:nvSpPr>
@@ -14055,7 +14106,7 @@
       </p:sp>
       <p:sp>
         <p:nvSpPr>
-          <p:cNvPr id="39" name="step-114"/>
+          <p:cNvPr id="39" name="step-116"/>
           <p:cNvSpPr/>
           <p:nvPr/>
         </p:nvSpPr>
@@ -14082,7 +14133,7 @@
       </p:sp>
       <p:sp>
         <p:nvSpPr>
-          <p:cNvPr id="40" name="txt-115"/>
+          <p:cNvPr id="40" name="txt-117"/>
           <p:cNvSpPr txBox="1"/>
           <p:nvPr/>
         </p:nvSpPr>
@@ -14121,7 +14172,7 @@
       </p:sp>
       <p:sp>
         <p:nvSpPr>
-          <p:cNvPr id="41" name="txt-116"/>
+          <p:cNvPr id="41" name="txt-118"/>
           <p:cNvSpPr txBox="1"/>
           <p:nvPr/>
         </p:nvSpPr>
@@ -14160,7 +14211,7 @@
       </p:sp>
       <p:sp>
         <p:nvSpPr>
-          <p:cNvPr id="42" name="step-117"/>
+          <p:cNvPr id="42" name="step-119"/>
           <p:cNvSpPr/>
           <p:nvPr/>
         </p:nvSpPr>
@@ -14187,7 +14238,7 @@
       </p:sp>
       <p:sp>
         <p:nvSpPr>
-          <p:cNvPr id="43" name="txt-118"/>
+          <p:cNvPr id="43" name="txt-120"/>
           <p:cNvSpPr txBox="1"/>
           <p:nvPr/>
         </p:nvSpPr>
@@ -14226,7 +14277,7 @@
       </p:sp>
       <p:sp>
         <p:nvSpPr>
-          <p:cNvPr id="44" name="txt-119"/>
+          <p:cNvPr id="44" name="txt-121"/>
           <p:cNvSpPr txBox="1"/>
           <p:nvPr/>
         </p:nvSpPr>
@@ -14265,7 +14316,7 @@
       </p:sp>
       <p:sp>
         <p:nvSpPr>
-          <p:cNvPr id="45" name="step-120"/>
+          <p:cNvPr id="45" name="step-122"/>
           <p:cNvSpPr/>
           <p:nvPr/>
         </p:nvSpPr>
@@ -14292,7 +14343,7 @@
       </p:sp>
       <p:sp>
         <p:nvSpPr>
-          <p:cNvPr id="46" name="txt-121"/>
+          <p:cNvPr id="46" name="txt-123"/>
           <p:cNvSpPr txBox="1"/>
           <p:nvPr/>
         </p:nvSpPr>
@@ -14331,7 +14382,7 @@
       </p:sp>
       <p:sp>
         <p:nvSpPr>
-          <p:cNvPr id="47" name="txt-122"/>
+          <p:cNvPr id="47" name="txt-124"/>
           <p:cNvSpPr txBox="1"/>
           <p:nvPr/>
         </p:nvSpPr>
@@ -14370,7 +14421,7 @@
       </p:sp>
       <p:sp>
         <p:nvSpPr>
-          <p:cNvPr id="48" name="step-123"/>
+          <p:cNvPr id="48" name="step-125"/>
           <p:cNvSpPr/>
           <p:nvPr/>
         </p:nvSpPr>
@@ -14397,7 +14448,7 @@
       </p:sp>
       <p:sp>
         <p:nvSpPr>
-          <p:cNvPr id="49" name="txt-124"/>
+          <p:cNvPr id="49" name="txt-126"/>
           <p:cNvSpPr txBox="1"/>
           <p:nvPr/>
         </p:nvSpPr>
@@ -14544,7 +14595,7 @@
       </p:sp>
       <p:sp>
         <p:nvSpPr>
-          <p:cNvPr id="3" name="card-125"/>
+          <p:cNvPr id="3" name="card-127"/>
           <p:cNvSpPr/>
           <p:nvPr/>
         </p:nvSpPr>
@@ -14571,7 +14622,7 @@
       </p:sp>
       <p:sp>
         <p:nvSpPr>
-          <p:cNvPr id="4" name="txt-126"/>
+          <p:cNvPr id="4" name="txt-128"/>
           <p:cNvSpPr txBox="1"/>
           <p:nvPr/>
         </p:nvSpPr>
@@ -14633,7 +14684,7 @@
       </p:sp>
       <p:sp>
         <p:nvSpPr>
-          <p:cNvPr id="5" name="txt-127"/>
+          <p:cNvPr id="5" name="txt-129"/>
           <p:cNvSpPr txBox="1"/>
           <p:nvPr/>
         </p:nvSpPr>
@@ -14672,7 +14723,7 @@
       </p:sp>
       <p:sp>
         <p:nvSpPr>
-          <p:cNvPr id="6" name="txt-128"/>
+          <p:cNvPr id="6" name="txt-130"/>
           <p:cNvSpPr txBox="1"/>
           <p:nvPr/>
         </p:nvSpPr>
@@ -14711,7 +14762,7 @@
       </p:sp>
       <p:graphicFrame>
         <p:nvGraphicFramePr>
-          <p:cNvPr id="8" name="tbl-129"/>
+          <p:cNvPr id="8" name="tbl-131"/>
           <p:cNvGraphicFramePr>
             <a:graphicFrameLocks noGrp="1"/>
           </p:cNvGraphicFramePr>
@@ -15848,7 +15899,7 @@
       </p:sp>
       <p:pic>
         <p:nvPicPr>
-          <p:cNvPr id="3" name="img-130" descr="Five-layer architecture: React console, FastAPI, adjudication engine, intelligence and tools, data and observability">    </p:cNvPr>
+          <p:cNvPr id="3" name="img-132" descr="Five-layer architecture: React console, FastAPI, adjudication engine, intelligence and tools, data and observability">    </p:cNvPr>
           <p:cNvPicPr>
             <a:picLocks noChangeAspect="1"/>
           </p:cNvPicPr>
@@ -15980,7 +16031,7 @@
       </p:sp>
       <p:sp>
         <p:nvSpPr>
-          <p:cNvPr id="3" name="node-131"/>
+          <p:cNvPr id="3" name="node-133"/>
           <p:cNvSpPr/>
           <p:nvPr/>
         </p:nvSpPr>
@@ -16007,7 +16058,7 @@
       </p:sp>
       <p:sp>
         <p:nvSpPr>
-          <p:cNvPr id="4" name="txt-132"/>
+          <p:cNvPr id="4" name="txt-134"/>
           <p:cNvSpPr txBox="1"/>
           <p:nvPr/>
         </p:nvSpPr>
@@ -16046,7 +16097,7 @@
       </p:sp>
       <p:sp>
         <p:nvSpPr>
-          <p:cNvPr id="5" name="node-133"/>
+          <p:cNvPr id="5" name="node-135"/>
           <p:cNvSpPr/>
           <p:nvPr/>
         </p:nvSpPr>
@@ -16073,7 +16124,7 @@
       </p:sp>
       <p:sp>
         <p:nvSpPr>
-          <p:cNvPr id="6" name="txt-134"/>
+          <p:cNvPr id="6" name="txt-136"/>
           <p:cNvSpPr txBox="1"/>
           <p:nvPr/>
         </p:nvSpPr>
@@ -16112,7 +16163,7 @@
       </p:sp>
       <p:sp>
         <p:nvSpPr>
-          <p:cNvPr id="7" name="node-135"/>
+          <p:cNvPr id="7" name="node-137"/>
           <p:cNvSpPr/>
           <p:nvPr/>
         </p:nvSpPr>
@@ -16139,7 +16190,7 @@
       </p:sp>
       <p:sp>
         <p:nvSpPr>
-          <p:cNvPr id="8" name="txt-136"/>
+          <p:cNvPr id="8" name="txt-138"/>
           <p:cNvSpPr txBox="1"/>
           <p:nvPr/>
         </p:nvSpPr>
@@ -16178,7 +16229,7 @@
       </p:sp>
       <p:sp>
         <p:nvSpPr>
-          <p:cNvPr id="9" name="node-137"/>
+          <p:cNvPr id="9" name="node-139"/>
           <p:cNvSpPr/>
           <p:nvPr/>
         </p:nvSpPr>
@@ -16205,7 +16256,7 @@
       </p:sp>
       <p:sp>
         <p:nvSpPr>
-          <p:cNvPr id="10" name="txt-138"/>
+          <p:cNvPr id="10" name="txt-140"/>
           <p:cNvSpPr txBox="1"/>
           <p:nvPr/>
         </p:nvSpPr>
@@ -16244,7 +16295,7 @@
       </p:sp>
       <p:sp>
         <p:nvSpPr>
-          <p:cNvPr id="11" name="node-139"/>
+          <p:cNvPr id="11" name="node-141"/>
           <p:cNvSpPr/>
           <p:nvPr/>
         </p:nvSpPr>
@@ -16271,7 +16322,7 @@
       </p:sp>
       <p:sp>
         <p:nvSpPr>
-          <p:cNvPr id="12" name="txt-140"/>
+          <p:cNvPr id="12" name="txt-142"/>
           <p:cNvSpPr txBox="1"/>
           <p:nvPr/>
         </p:nvSpPr>
@@ -16310,7 +16361,7 @@
       </p:sp>
       <p:sp>
         <p:nvSpPr>
-          <p:cNvPr id="13" name="node-141"/>
+          <p:cNvPr id="13" name="node-143"/>
           <p:cNvSpPr/>
           <p:nvPr/>
         </p:nvSpPr>
@@ -16337,7 +16388,7 @@
       </p:sp>
       <p:sp>
         <p:nvSpPr>
-          <p:cNvPr id="14" name="txt-142"/>
+          <p:cNvPr id="14" name="txt-144"/>
           <p:cNvSpPr txBox="1"/>
           <p:nvPr/>
         </p:nvSpPr>
@@ -16376,7 +16427,7 @@
       </p:sp>
       <p:sp>
         <p:nvSpPr>
-          <p:cNvPr id="15" name="node-143"/>
+          <p:cNvPr id="15" name="node-145"/>
           <p:cNvSpPr/>
           <p:nvPr/>
         </p:nvSpPr>
@@ -16403,7 +16454,7 @@
       </p:sp>
       <p:sp>
         <p:nvSpPr>
-          <p:cNvPr id="16" name="txt-144"/>
+          <p:cNvPr id="16" name="txt-146"/>
           <p:cNvSpPr txBox="1"/>
           <p:nvPr/>
         </p:nvSpPr>
@@ -16442,7 +16493,7 @@
       </p:sp>
       <p:sp>
         <p:nvSpPr>
-          <p:cNvPr id="17" name="node-145"/>
+          <p:cNvPr id="17" name="node-147"/>
           <p:cNvSpPr/>
           <p:nvPr/>
         </p:nvSpPr>
@@ -16469,7 +16520,7 @@
       </p:sp>
       <p:sp>
         <p:nvSpPr>
-          <p:cNvPr id="18" name="txt-146"/>
+          <p:cNvPr id="18" name="txt-148"/>
           <p:cNvSpPr txBox="1"/>
           <p:nvPr/>
         </p:nvSpPr>
@@ -16508,7 +16559,7 @@
       </p:sp>
       <p:sp>
         <p:nvSpPr>
-          <p:cNvPr id="19" name="node-147"/>
+          <p:cNvPr id="19" name="node-149"/>
           <p:cNvSpPr/>
           <p:nvPr/>
         </p:nvSpPr>
@@ -16535,7 +16586,7 @@
       </p:sp>
       <p:sp>
         <p:nvSpPr>
-          <p:cNvPr id="20" name="txt-148"/>
+          <p:cNvPr id="20" name="txt-150"/>
           <p:cNvSpPr txBox="1"/>
           <p:nvPr/>
         </p:nvSpPr>
@@ -16574,7 +16625,7 @@
       </p:sp>
       <p:sp>
         <p:nvSpPr>
-          <p:cNvPr id="21" name="node-149"/>
+          <p:cNvPr id="21" name="node-151"/>
           <p:cNvSpPr/>
           <p:nvPr/>
         </p:nvSpPr>
@@ -16601,7 +16652,7 @@
       </p:sp>
       <p:sp>
         <p:nvSpPr>
-          <p:cNvPr id="22" name="txt-150"/>
+          <p:cNvPr id="22" name="txt-152"/>
           <p:cNvSpPr txBox="1"/>
           <p:nvPr/>
         </p:nvSpPr>
@@ -16640,7 +16691,7 @@
       </p:sp>
       <p:sp>
         <p:nvSpPr>
-          <p:cNvPr id="23" name="txt-151"/>
+          <p:cNvPr id="23" name="txt-153"/>
           <p:cNvSpPr txBox="1"/>
           <p:nvPr/>
         </p:nvSpPr>
@@ -16679,7 +16730,7 @@
       </p:sp>
       <p:sp>
         <p:nvSpPr>
-          <p:cNvPr id="24" name="txt-152"/>
+          <p:cNvPr id="24" name="txt-154"/>
           <p:cNvSpPr txBox="1"/>
           <p:nvPr/>
         </p:nvSpPr>
@@ -16718,7 +16769,7 @@
       </p:sp>
       <p:sp>
         <p:nvSpPr>
-          <p:cNvPr id="25" name="txt-153"/>
+          <p:cNvPr id="25" name="txt-155"/>
           <p:cNvSpPr txBox="1"/>
           <p:nvPr/>
         </p:nvSpPr>
@@ -16757,7 +16808,7 @@
       </p:sp>
       <p:sp>
         <p:nvSpPr>
-          <p:cNvPr id="26" name="txt-154"/>
+          <p:cNvPr id="26" name="txt-156"/>
           <p:cNvSpPr txBox="1"/>
           <p:nvPr/>
         </p:nvSpPr>
@@ -16796,7 +16847,7 @@
       </p:sp>
       <p:sp>
         <p:nvSpPr>
-          <p:cNvPr id="27" name="txt-155"/>
+          <p:cNvPr id="27" name="txt-157"/>
           <p:cNvSpPr txBox="1"/>
           <p:nvPr/>
         </p:nvSpPr>
@@ -16835,7 +16886,7 @@
       </p:sp>
       <p:sp>
         <p:nvSpPr>
-          <p:cNvPr id="28" name="txt-156"/>
+          <p:cNvPr id="28" name="txt-158"/>
           <p:cNvSpPr txBox="1"/>
           <p:nvPr/>
         </p:nvSpPr>
@@ -16874,7 +16925,7 @@
       </p:sp>
       <p:sp>
         <p:nvSpPr>
-          <p:cNvPr id="29" name="txt-157"/>
+          <p:cNvPr id="29" name="txt-159"/>
           <p:cNvSpPr txBox="1"/>
           <p:nvPr/>
         </p:nvSpPr>
@@ -16913,7 +16964,7 @@
       </p:sp>
       <p:sp>
         <p:nvSpPr>
-          <p:cNvPr id="30" name="txt-158"/>
+          <p:cNvPr id="30" name="txt-160"/>
           <p:cNvSpPr txBox="1"/>
           <p:nvPr/>
         </p:nvSpPr>
@@ -16952,7 +17003,7 @@
       </p:sp>
       <p:sp>
         <p:nvSpPr>
-          <p:cNvPr id="31" name="card-159"/>
+          <p:cNvPr id="31" name="card-161"/>
           <p:cNvSpPr/>
           <p:nvPr/>
         </p:nvSpPr>
@@ -16979,7 +17030,7 @@
       </p:sp>
       <p:sp>
         <p:nvSpPr>
-          <p:cNvPr id="32" name="txt-160"/>
+          <p:cNvPr id="32" name="txt-162"/>
           <p:cNvSpPr txBox="1"/>
           <p:nvPr/>
         </p:nvSpPr>

</xml_diff>